<commit_message>
update 23 dec 2025
</commit_message>
<xml_diff>
--- a/reports/PowerBI/HeMAB_QA_Dashboard_Latest.pptx
+++ b/reports/PowerBI/HeMAB_QA_Dashboard_Latest.pptx
@@ -6418,7 +6418,7 @@
                 <a:ea typeface="Segoe UI" charset="0"/>
                 <a:cs typeface="Segoe UI" charset="0"/>
               </a:rPr>
-              <a:t>12/20/2025 1:20:41 AM UTC</a:t>
+              <a:t>12/24/2025 1:59:08 AM UTC</a:t>
             </a:r>
           </a:p>
         </p:txBody>
@@ -6475,7 +6475,7 @@
                 <a:ea typeface="Segoe UI" charset="0"/>
                 <a:cs typeface="Segoe UI" charset="0"/>
               </a:rPr>
-              <a:t>12/20/2025 1:19:47 AM UTC</a:t>
+              <a:t>12/24/2025 1:57:39 AM UTC</a:t>
             </a:r>
             <a:endParaRPr lang="en-US" sz="900" b="0" i="0" dirty="0">
               <a:solidFill>
@@ -6588,7 +6588,7 @@
           <p:nvPr/>
         </p:nvPicPr>
         <p:blipFill>
-          <a:blip xmlns:r="http://schemas.openxmlformats.org/officeDocument/2006/relationships" xmlns:a="http://schemas.openxmlformats.org/drawingml/2006/main" r:embed="imgId44594337"/>
+          <a:blip xmlns:r="http://schemas.openxmlformats.org/officeDocument/2006/relationships" xmlns:a="http://schemas.openxmlformats.org/drawingml/2006/main" r:embed="imgId44710881"/>
           <a:stretch xmlns:a="http://schemas.openxmlformats.org/drawingml/2006/main">
             <a:fillRect/>
           </a:stretch>
@@ -6654,7 +6654,7 @@
           <p:nvPr/>
         </p:nvPicPr>
         <p:blipFill>
-          <a:blip xmlns:r="http://schemas.openxmlformats.org/officeDocument/2006/relationships" xmlns:a="http://schemas.openxmlformats.org/drawingml/2006/main" r:embed="imgId44594339"/>
+          <a:blip xmlns:r="http://schemas.openxmlformats.org/officeDocument/2006/relationships" xmlns:a="http://schemas.openxmlformats.org/drawingml/2006/main" r:embed="imgId44710883"/>
           <a:stretch xmlns:a="http://schemas.openxmlformats.org/drawingml/2006/main">
             <a:fillRect/>
           </a:stretch>
@@ -6720,7 +6720,7 @@
           <p:nvPr/>
         </p:nvPicPr>
         <p:blipFill>
-          <a:blip xmlns:r="http://schemas.openxmlformats.org/officeDocument/2006/relationships" xmlns:a="http://schemas.openxmlformats.org/drawingml/2006/main" r:embed="imgId44594340"/>
+          <a:blip xmlns:r="http://schemas.openxmlformats.org/officeDocument/2006/relationships" xmlns:a="http://schemas.openxmlformats.org/drawingml/2006/main" r:embed="imgId44710884"/>
           <a:stretch xmlns:a="http://schemas.openxmlformats.org/drawingml/2006/main">
             <a:fillRect/>
           </a:stretch>
@@ -6786,7 +6786,7 @@
           <p:nvPr/>
         </p:nvPicPr>
         <p:blipFill>
-          <a:blip xmlns:r="http://schemas.openxmlformats.org/officeDocument/2006/relationships" xmlns:a="http://schemas.openxmlformats.org/drawingml/2006/main" r:embed="imgId44594341"/>
+          <a:blip xmlns:r="http://schemas.openxmlformats.org/officeDocument/2006/relationships" xmlns:a="http://schemas.openxmlformats.org/drawingml/2006/main" r:embed="imgId44710885"/>
           <a:stretch xmlns:a="http://schemas.openxmlformats.org/drawingml/2006/main">
             <a:fillRect/>
           </a:stretch>
@@ -6852,7 +6852,7 @@
           <p:nvPr/>
         </p:nvPicPr>
         <p:blipFill>
-          <a:blip xmlns:r="http://schemas.openxmlformats.org/officeDocument/2006/relationships" xmlns:a="http://schemas.openxmlformats.org/drawingml/2006/main" r:embed="imgId44594342"/>
+          <a:blip xmlns:r="http://schemas.openxmlformats.org/officeDocument/2006/relationships" xmlns:a="http://schemas.openxmlformats.org/drawingml/2006/main" r:embed="imgId44710886"/>
           <a:stretch xmlns:a="http://schemas.openxmlformats.org/drawingml/2006/main">
             <a:fillRect/>
           </a:stretch>
@@ -6918,7 +6918,7 @@
           <p:nvPr/>
         </p:nvPicPr>
         <p:blipFill>
-          <a:blip xmlns:r="http://schemas.openxmlformats.org/officeDocument/2006/relationships" xmlns:a="http://schemas.openxmlformats.org/drawingml/2006/main" r:embed="imgId44594343"/>
+          <a:blip xmlns:r="http://schemas.openxmlformats.org/officeDocument/2006/relationships" xmlns:a="http://schemas.openxmlformats.org/drawingml/2006/main" r:embed="imgId44710887"/>
           <a:stretch xmlns:a="http://schemas.openxmlformats.org/drawingml/2006/main">
             <a:fillRect/>
           </a:stretch>
@@ -6984,7 +6984,7 @@
           <p:nvPr/>
         </p:nvPicPr>
         <p:blipFill>
-          <a:blip xmlns:r="http://schemas.openxmlformats.org/officeDocument/2006/relationships" xmlns:a="http://schemas.openxmlformats.org/drawingml/2006/main" r:embed="imgId44594344"/>
+          <a:blip xmlns:r="http://schemas.openxmlformats.org/officeDocument/2006/relationships" xmlns:a="http://schemas.openxmlformats.org/drawingml/2006/main" r:embed="imgId44710888"/>
           <a:stretch xmlns:a="http://schemas.openxmlformats.org/drawingml/2006/main">
             <a:fillRect/>
           </a:stretch>
@@ -7050,7 +7050,7 @@
           <p:nvPr/>
         </p:nvPicPr>
         <p:blipFill>
-          <a:blip xmlns:r="http://schemas.openxmlformats.org/officeDocument/2006/relationships" xmlns:a="http://schemas.openxmlformats.org/drawingml/2006/main" r:embed="imgId44594345"/>
+          <a:blip xmlns:r="http://schemas.openxmlformats.org/officeDocument/2006/relationships" xmlns:a="http://schemas.openxmlformats.org/drawingml/2006/main" r:embed="imgId44710889"/>
           <a:stretch xmlns:a="http://schemas.openxmlformats.org/drawingml/2006/main">
             <a:fillRect/>
           </a:stretch>
@@ -7116,7 +7116,7 @@
           <p:nvPr/>
         </p:nvPicPr>
         <p:blipFill>
-          <a:blip xmlns:r="http://schemas.openxmlformats.org/officeDocument/2006/relationships" xmlns:a="http://schemas.openxmlformats.org/drawingml/2006/main" r:embed="imgId44594346"/>
+          <a:blip xmlns:r="http://schemas.openxmlformats.org/officeDocument/2006/relationships" xmlns:a="http://schemas.openxmlformats.org/drawingml/2006/main" r:embed="imgId44710890"/>
           <a:stretch xmlns:a="http://schemas.openxmlformats.org/drawingml/2006/main">
             <a:fillRect/>
           </a:stretch>
@@ -7182,7 +7182,7 @@
           <p:nvPr/>
         </p:nvPicPr>
         <p:blipFill>
-          <a:blip xmlns:r="http://schemas.openxmlformats.org/officeDocument/2006/relationships" xmlns:a="http://schemas.openxmlformats.org/drawingml/2006/main" r:embed="imgId44594347"/>
+          <a:blip xmlns:r="http://schemas.openxmlformats.org/officeDocument/2006/relationships" xmlns:a="http://schemas.openxmlformats.org/drawingml/2006/main" r:embed="imgId44710891"/>
           <a:stretch xmlns:a="http://schemas.openxmlformats.org/drawingml/2006/main">
             <a:fillRect/>
           </a:stretch>

</xml_diff>